<commit_message>
feat(PW-402): add recon correlation delivery
</commit_message>
<xml_diff>
--- a/presentation/purplewatch-soutenance-20min.pptx
+++ b/presentation/purplewatch-soutenance-20min.pptx
@@ -2986,7 +2986,7 @@
                 <a:ea typeface="Bitstream Charter"/>
                 <a:cs typeface="Bitstream Charter"/>
               </a:rPr>
-              <a:t>Une séquence courte, avec preuves de secours prêtes</a:t>
+              <a:t>Deux adversaries Caldera reproductibles ; données exclusivement fictives</a:t>
             </a:r>
           </a:p>
         </p:txBody>
@@ -3049,7 +3049,9 @@
                 <a:ea typeface="Bitstream Charter"/>
                 <a:cs typeface="Bitstream Charter"/>
               </a:rPr>
-              <a:t>0:00 à 0:30</a:t>
+              <a:t>0:00 à 0:30
+Montrer agents et services
+PW-LINUX-01 + Wazuh</a:t>
             </a:r>
           </a:p>
           <a:p xmlns:a="http://schemas.openxmlformats.org/drawingml/2006/main">
@@ -3063,17 +3065,6 @@
                 <a:cs typeface="Bitstream Charter"/>
               </a:defRPr>
             </a:pPr>
-            <a:r>
-              <a:rPr sz="1575" b="0">
-                <a:solidFill>
-                  <a:srgbClr val="EAF2FF"/>
-                </a:solidFill>
-                <a:latin typeface="Bitstream Charter"/>
-                <a:ea typeface="Bitstream Charter"/>
-                <a:cs typeface="Bitstream Charter"/>
-              </a:rPr>
-              <a:t>Vérifier agents et services</a:t>
-            </a:r>
           </a:p>
           <a:p xmlns:a="http://schemas.openxmlformats.org/drawingml/2006/main">
             <a:pPr>
@@ -3086,17 +3077,6 @@
                 <a:cs typeface="Bitstream Charter"/>
               </a:defRPr>
             </a:pPr>
-            <a:r>
-              <a:rPr sz="1575" b="0">
-                <a:solidFill>
-                  <a:srgbClr val="EAF2FF"/>
-                </a:solidFill>
-                <a:latin typeface="Bitstream Charter"/>
-                <a:ea typeface="Bitstream Charter"/>
-                <a:cs typeface="Bitstream Charter"/>
-              </a:rPr>
-              <a:t>Sandcat actif</a:t>
-            </a:r>
           </a:p>
         </p:txBody>
       </p:sp>
@@ -3158,7 +3138,9 @@
                 <a:ea typeface="Bitstream Charter"/>
                 <a:cs typeface="Bitstream Charter"/>
               </a:rPr>
-              <a:t>0:30 à 1:30</a:t>
+              <a:t>0:30 à 6:30
+Lancer le scénario complet
+8 abilities, 5 tactiques</a:t>
             </a:r>
           </a:p>
           <a:p xmlns:a="http://schemas.openxmlformats.org/drawingml/2006/main">
@@ -3172,17 +3154,6 @@
                 <a:cs typeface="Bitstream Charter"/>
               </a:defRPr>
             </a:pPr>
-            <a:r>
-              <a:rPr sz="1575" b="0">
-                <a:solidFill>
-                  <a:srgbClr val="EAF2FF"/>
-                </a:solidFill>
-                <a:latin typeface="Bitstream Charter"/>
-                <a:ea typeface="Bitstream Charter"/>
-                <a:cs typeface="Bitstream Charter"/>
-              </a:rPr>
-              <a:t>Lancer T1057 Windows dans Caldera</a:t>
-            </a:r>
           </a:p>
           <a:p xmlns:a="http://schemas.openxmlformats.org/drawingml/2006/main">
             <a:pPr>
@@ -3195,17 +3166,6 @@
                 <a:cs typeface="Bitstream Charter"/>
               </a:defRPr>
             </a:pPr>
-            <a:r>
-              <a:rPr sz="1575" b="0">
-                <a:solidFill>
-                  <a:srgbClr val="EAF2FF"/>
-                </a:solidFill>
-                <a:latin typeface="Bitstream Charter"/>
-                <a:ea typeface="Bitstream Charter"/>
-                <a:cs typeface="Bitstream Charter"/>
-              </a:rPr>
-              <a:t>Montrer le success</a:t>
-            </a:r>
           </a:p>
         </p:txBody>
       </p:sp>
@@ -3267,7 +3227,9 @@
                 <a:ea typeface="Bitstream Charter"/>
                 <a:cs typeface="Bitstream Charter"/>
               </a:rPr>
-              <a:t>1:30 à 2:30</a:t>
+              <a:t>6:30 à 8:00
+Montrer 8 alertes Wazuh
+Puis la corrélation 100112</a:t>
             </a:r>
           </a:p>
           <a:p xmlns:a="http://schemas.openxmlformats.org/drawingml/2006/main">
@@ -3281,17 +3243,6 @@
                 <a:cs typeface="Bitstream Charter"/>
               </a:defRPr>
             </a:pPr>
-            <a:r>
-              <a:rPr sz="1575" b="0">
-                <a:solidFill>
-                  <a:srgbClr val="EAF2FF"/>
-                </a:solidFill>
-                <a:latin typeface="Bitstream Charter"/>
-                <a:ea typeface="Bitstream Charter"/>
-                <a:cs typeface="Bitstream Charter"/>
-              </a:rPr>
-              <a:t>Afficher Wazuh 100101</a:t>
-            </a:r>
           </a:p>
           <a:p xmlns:a="http://schemas.openxmlformats.org/drawingml/2006/main">
             <a:pPr>
@@ -3304,17 +3255,6 @@
                 <a:cs typeface="Bitstream Charter"/>
               </a:defRPr>
             </a:pPr>
-            <a:r>
-              <a:rPr sz="1575" b="0">
-                <a:solidFill>
-                  <a:srgbClr val="EAF2FF"/>
-                </a:solidFill>
-                <a:latin typeface="Bitstream Charter"/>
-                <a:ea typeface="Bitstream Charter"/>
-                <a:cs typeface="Bitstream Charter"/>
-              </a:rPr>
-              <a:t>Comparer les horaires</a:t>
-            </a:r>
           </a:p>
         </p:txBody>
       </p:sp>
@@ -3370,7 +3310,7 @@
                 <a:ea typeface="Bitstream Charter"/>
                 <a:cs typeface="Bitstream Charter"/>
               </a:rPr>
-              <a:t>Plan B : démonstration Linux complète en direct, puis captures Windows datées.</a:t>
+              <a:t>Preuves datées : 8/8 Caldera → 8/8 Wazuh ; 100112 corrèle uname, ps et ip sur le même hôte.</a:t>
             </a:r>
           </a:p>
         </p:txBody>
@@ -3427,7 +3367,7 @@
                 <a:ea typeface="Bitstream Charter"/>
                 <a:cs typeface="Bitstream Charter"/>
               </a:rPr>
-              <a:t>Prévoir uniquement les VMs nécessaires : le PC hôte dispose d’environ 8 Go de RAM.</a:t>
+              <a:t>Plan B : captures Caldera/Wazuh et journal d’attaque si la démonstration en direct est lente.</a:t>
             </a:r>
           </a:p>
         </p:txBody>
@@ -3657,7 +3597,7 @@
                 <a:ea typeface="Bitstream Charter"/>
                 <a:cs typeface="Bitstream Charter"/>
               </a:rPr>
-              <a:t>PurpleWatch valide une chaîne défensive mesurable.</a:t>
+              <a:t>Deux parcours reproductibles et une corrélation Wazuh validée.</a:t>
             </a:r>
           </a:p>
         </p:txBody>
@@ -3720,7 +3660,8 @@
                 <a:ea typeface="Bitstream Charter"/>
                 <a:cs typeface="Bitstream Charter"/>
               </a:rPr>
-              <a:t>6 techniques ATT&amp;CK validées</a:t>
+              <a:t>8 techniques Linux
+5 tactiques ATT&amp;CK</a:t>
             </a:r>
           </a:p>
           <a:p xmlns:a="http://schemas.openxmlformats.org/drawingml/2006/main">
@@ -3734,17 +3675,6 @@
                 <a:cs typeface="Bitstream Charter"/>
               </a:defRPr>
             </a:pPr>
-            <a:r>
-              <a:rPr sz="1725" b="0">
-                <a:solidFill>
-                  <a:srgbClr val="EAF2FF"/>
-                </a:solidFill>
-                <a:latin typeface="Bitstream Charter"/>
-                <a:ea typeface="Bitstream Charter"/>
-                <a:cs typeface="Bitstream Charter"/>
-              </a:rPr>
-              <a:t>Windows et Linux</a:t>
-            </a:r>
           </a:p>
         </p:txBody>
       </p:sp>
@@ -3806,7 +3736,8 @@
                 <a:ea typeface="Bitstream Charter"/>
                 <a:cs typeface="Bitstream Charter"/>
               </a:rPr>
-              <a:t>Détections Wazuh reliées</a:t>
+              <a:t>8/8 alertes mult tactiques
+Corrélation Wazuh 100112</a:t>
             </a:r>
           </a:p>
           <a:p xmlns:a="http://schemas.openxmlformats.org/drawingml/2006/main">
@@ -3820,17 +3751,6 @@
                 <a:cs typeface="Bitstream Charter"/>
               </a:defRPr>
             </a:pPr>
-            <a:r>
-              <a:rPr sz="1725" b="0">
-                <a:solidFill>
-                  <a:srgbClr val="EAF2FF"/>
-                </a:solidFill>
-                <a:latin typeface="Bitstream Charter"/>
-                <a:ea typeface="Bitstream Charter"/>
-                <a:cs typeface="Bitstream Charter"/>
-              </a:rPr>
-              <a:t>à Sysmon ou auditd</a:t>
-            </a:r>
           </a:p>
         </p:txBody>
       </p:sp>
@@ -3892,7 +3812,8 @@
                 <a:ea typeface="Bitstream Charter"/>
                 <a:cs typeface="Bitstream Charter"/>
               </a:rPr>
-              <a:t>GAP documentés</a:t>
+              <a:t>15/15 reconnaissance
+P50 0,874 s · P95 1,178 s</a:t>
             </a:r>
           </a:p>
           <a:p xmlns:a="http://schemas.openxmlformats.org/drawingml/2006/main">
@@ -3906,17 +3827,6 @@
                 <a:cs typeface="Bitstream Charter"/>
               </a:defRPr>
             </a:pPr>
-            <a:r>
-              <a:rPr sz="1725" b="0">
-                <a:solidFill>
-                  <a:srgbClr val="EAF2FF"/>
-                </a:solidFill>
-                <a:latin typeface="Bitstream Charter"/>
-                <a:ea typeface="Bitstream Charter"/>
-                <a:cs typeface="Bitstream Charter"/>
-              </a:rPr>
-              <a:t>Corrections et retests</a:t>
-            </a:r>
           </a:p>
         </p:txBody>
       </p:sp>
@@ -5212,7 +5122,9 @@
                 <a:ea typeface="Bitstream Charter"/>
                 <a:cs typeface="Bitstream Charter"/>
               </a:rPr>
-              <a:t>PW-CALDERA-01</a:t>
+              <a:t>PW-CALDERA-01 · Scaleway
+Caldera, orchestration
+Tailscale · HTTP 8888</a:t>
             </a:r>
           </a:p>
           <a:p xmlns:a="http://schemas.openxmlformats.org/drawingml/2006/main">
@@ -5226,17 +5138,6 @@
                 <a:cs typeface="Bitstream Charter"/>
               </a:defRPr>
             </a:pPr>
-            <a:r>
-              <a:rPr sz="1500" b="0">
-                <a:solidFill>
-                  <a:srgbClr val="EAF2FF"/>
-                </a:solidFill>
-                <a:latin typeface="Bitstream Charter"/>
-                <a:ea typeface="Bitstream Charter"/>
-                <a:cs typeface="Bitstream Charter"/>
-              </a:rPr>
-              <a:t>Orchestration Caldera</a:t>
-            </a:r>
           </a:p>
           <a:p xmlns:a="http://schemas.openxmlformats.org/drawingml/2006/main">
             <a:pPr>
@@ -5249,17 +5150,6 @@
                 <a:cs typeface="Bitstream Charter"/>
               </a:defRPr>
             </a:pPr>
-            <a:r>
-              <a:rPr sz="1500" b="0">
-                <a:solidFill>
-                  <a:srgbClr val="EAF2FF"/>
-                </a:solidFill>
-                <a:latin typeface="Bitstream Charter"/>
-                <a:ea typeface="Bitstream Charter"/>
-                <a:cs typeface="Bitstream Charter"/>
-              </a:rPr>
-              <a:t>Tailscale 100.103.199.63</a:t>
-            </a:r>
           </a:p>
         </p:txBody>
       </p:sp>
@@ -5321,7 +5211,9 @@
                 <a:ea typeface="Bitstream Charter"/>
                 <a:cs typeface="Bitstream Charter"/>
               </a:rPr>
-              <a:t>PW-WIN11-01</a:t>
+              <a:t>PW-WIN11-01 · VirtualBox
+Sandcat, Sysmon
+Agent Wazuh</a:t>
             </a:r>
           </a:p>
           <a:p xmlns:a="http://schemas.openxmlformats.org/drawingml/2006/main">
@@ -5335,17 +5227,6 @@
                 <a:cs typeface="Bitstream Charter"/>
               </a:defRPr>
             </a:pPr>
-            <a:r>
-              <a:rPr sz="1500" b="0">
-                <a:solidFill>
-                  <a:srgbClr val="EAF2FF"/>
-                </a:solidFill>
-                <a:latin typeface="Bitstream Charter"/>
-                <a:ea typeface="Bitstream Charter"/>
-                <a:cs typeface="Bitstream Charter"/>
-              </a:rPr>
-              <a:t>Sandcat, Sysmon</a:t>
-            </a:r>
           </a:p>
           <a:p xmlns:a="http://schemas.openxmlformats.org/drawingml/2006/main">
             <a:pPr>
@@ -5358,17 +5239,6 @@
                 <a:cs typeface="Bitstream Charter"/>
               </a:defRPr>
             </a:pPr>
-            <a:r>
-              <a:rPr sz="1500" b="0">
-                <a:solidFill>
-                  <a:srgbClr val="EAF2FF"/>
-                </a:solidFill>
-                <a:latin typeface="Bitstream Charter"/>
-                <a:ea typeface="Bitstream Charter"/>
-                <a:cs typeface="Bitstream Charter"/>
-              </a:rPr>
-              <a:t>Agent Wazuh</a:t>
-            </a:r>
           </a:p>
         </p:txBody>
       </p:sp>
@@ -5430,7 +5300,9 @@
                 <a:ea typeface="Bitstream Charter"/>
                 <a:cs typeface="Bitstream Charter"/>
               </a:rPr>
-              <a:t>PW-LINUX-01</a:t>
+              <a:t>PW-LINUX-01 · Scaleway
+Sandcat, auditd
+Agent Wazuh</a:t>
             </a:r>
           </a:p>
           <a:p xmlns:a="http://schemas.openxmlformats.org/drawingml/2006/main">
@@ -5444,17 +5316,6 @@
                 <a:cs typeface="Bitstream Charter"/>
               </a:defRPr>
             </a:pPr>
-            <a:r>
-              <a:rPr sz="1500" b="0">
-                <a:solidFill>
-                  <a:srgbClr val="EAF2FF"/>
-                </a:solidFill>
-                <a:latin typeface="Bitstream Charter"/>
-                <a:ea typeface="Bitstream Charter"/>
-                <a:cs typeface="Bitstream Charter"/>
-              </a:rPr>
-              <a:t>Sandcat, auditd</a:t>
-            </a:r>
           </a:p>
           <a:p xmlns:a="http://schemas.openxmlformats.org/drawingml/2006/main">
             <a:pPr>
@@ -5467,17 +5328,6 @@
                 <a:cs typeface="Bitstream Charter"/>
               </a:defRPr>
             </a:pPr>
-            <a:r>
-              <a:rPr sz="1500" b="0">
-                <a:solidFill>
-                  <a:srgbClr val="EAF2FF"/>
-                </a:solidFill>
-                <a:latin typeface="Bitstream Charter"/>
-                <a:ea typeface="Bitstream Charter"/>
-                <a:cs typeface="Bitstream Charter"/>
-              </a:rPr>
-              <a:t>Agent Wazuh</a:t>
-            </a:r>
           </a:p>
         </p:txBody>
       </p:sp>
@@ -5539,7 +5389,9 @@
                 <a:ea typeface="Bitstream Charter"/>
                 <a:cs typeface="Bitstream Charter"/>
               </a:rPr>
-              <a:t>PW-WAZUH-01</a:t>
+              <a:t>PW-WAZUH-01 · VirtualBox
+Manager, Indexer
+Dashboard</a:t>
             </a:r>
           </a:p>
           <a:p xmlns:a="http://schemas.openxmlformats.org/drawingml/2006/main">
@@ -5553,17 +5405,6 @@
                 <a:cs typeface="Bitstream Charter"/>
               </a:defRPr>
             </a:pPr>
-            <a:r>
-              <a:rPr sz="1500" b="0">
-                <a:solidFill>
-                  <a:srgbClr val="EAF2FF"/>
-                </a:solidFill>
-                <a:latin typeface="Bitstream Charter"/>
-                <a:ea typeface="Bitstream Charter"/>
-                <a:cs typeface="Bitstream Charter"/>
-              </a:rPr>
-              <a:t>Manager, Indexer</a:t>
-            </a:r>
           </a:p>
           <a:p xmlns:a="http://schemas.openxmlformats.org/drawingml/2006/main">
             <a:pPr>
@@ -5576,17 +5417,6 @@
                 <a:cs typeface="Bitstream Charter"/>
               </a:defRPr>
             </a:pPr>
-            <a:r>
-              <a:rPr sz="1500" b="0">
-                <a:solidFill>
-                  <a:srgbClr val="EAF2FF"/>
-                </a:solidFill>
-                <a:latin typeface="Bitstream Charter"/>
-                <a:ea typeface="Bitstream Charter"/>
-                <a:cs typeface="Bitstream Charter"/>
-              </a:rPr>
-              <a:t>Threat Hunting</a:t>
-            </a:r>
           </a:p>
         </p:txBody>
       </p:sp>
@@ -5642,7 +5472,7 @@
                 <a:ea typeface="Bitstream Charter"/>
                 <a:cs typeface="Bitstream Charter"/>
               </a:rPr>
-              <a:t>Tailscale transporte les communications chiffrées entre les composants. Wazuh centralise les événements de Windows et Linux.</a:t>
+              <a:t>Flux privés : Caldera → Sandcat HTTP 8888 via Tailscale ; agents → Wazuh TCP 1514 via Tailscale (Linux) ou réseau host-only (Windows).</a:t>
             </a:r>
           </a:p>
         </p:txBody>
@@ -6877,7 +6707,7 @@
                 <a:ea typeface="Bitstream Charter"/>
                 <a:cs typeface="Bitstream Charter"/>
               </a:rPr>
-              <a:t>Couverture MITRE ATT&amp;CK validée</a:t>
+              <a:t>Couverture ATT&amp;CK : 5 tactiques Linux</a:t>
             </a:r>
           </a:p>
         </p:txBody>
@@ -7398,7 +7228,8 @@
                 <a:ea typeface="Bitstream Charter"/>
                 <a:cs typeface="Bitstream Charter"/>
               </a:rPr>
-              <a:t>T1082  uname</a:t>
+              <a:t>Discovery : T1082, T1057, T1016, T1087.001
+Règles 100104 à 100107</a:t>
             </a:r>
           </a:p>
           <a:p xmlns:a="http://schemas.openxmlformats.org/drawingml/2006/main">
@@ -7412,17 +7243,6 @@
                 <a:cs typeface="Bitstream Charter"/>
               </a:defRPr>
             </a:pPr>
-            <a:r>
-              <a:rPr sz="1575" b="0">
-                <a:solidFill>
-                  <a:srgbClr val="EAF2FF"/>
-                </a:solidFill>
-                <a:latin typeface="Bitstream Charter"/>
-                <a:ea typeface="Bitstream Charter"/>
-                <a:cs typeface="Bitstream Charter"/>
-              </a:rPr>
-              <a:t>Règle 100104</a:t>
-            </a:r>
           </a:p>
         </p:txBody>
       </p:sp>
@@ -7484,7 +7304,8 @@
                 <a:ea typeface="Bitstream Charter"/>
                 <a:cs typeface="Bitstream Charter"/>
               </a:rPr>
-              <a:t>T1057  ps et Atomic ps</a:t>
+              <a:t>Execution T1059.004 · Credential Access T1552.001
+Collection T1119 · Defense Evasion T1036.005</a:t>
             </a:r>
           </a:p>
           <a:p xmlns:a="http://schemas.openxmlformats.org/drawingml/2006/main">
@@ -7498,17 +7319,6 @@
                 <a:cs typeface="Bitstream Charter"/>
               </a:defRPr>
             </a:pPr>
-            <a:r>
-              <a:rPr sz="1575" b="0">
-                <a:solidFill>
-                  <a:srgbClr val="EAF2FF"/>
-                </a:solidFill>
-                <a:latin typeface="Bitstream Charter"/>
-                <a:ea typeface="Bitstream Charter"/>
-                <a:cs typeface="Bitstream Charter"/>
-              </a:rPr>
-              <a:t>Règle 100105 et 92604</a:t>
-            </a:r>
           </a:p>
         </p:txBody>
       </p:sp>
@@ -8288,7 +8098,7 @@
                 <a:ea typeface="Bitstream Charter"/>
                 <a:cs typeface="Bitstream Charter"/>
               </a:rPr>
-              <a:t>Preuves Linux et Atomic Red Team</a:t>
+              <a:t>Preuves Linux : mesures et corrélation</a:t>
             </a:r>
           </a:p>
         </p:txBody>
@@ -8351,7 +8161,9 @@
                 <a:ea typeface="Bitstream Charter"/>
                 <a:cs typeface="Bitstream Charter"/>
               </a:rPr>
-              <a:t>T1082 Linux</a:t>
+              <a:t>5 séquences Caldera
+15/15 alertes attendues
+T1082 → T1057 → T1016</a:t>
             </a:r>
           </a:p>
           <a:p xmlns:a="http://schemas.openxmlformats.org/drawingml/2006/main">
@@ -8365,17 +8177,6 @@
                 <a:cs typeface="Bitstream Charter"/>
               </a:defRPr>
             </a:pPr>
-            <a:r>
-              <a:rPr sz="1650" b="0">
-                <a:solidFill>
-                  <a:srgbClr val="EAF2FF"/>
-                </a:solidFill>
-                <a:latin typeface="Bitstream Charter"/>
-                <a:ea typeface="Bitstream Charter"/>
-                <a:cs typeface="Bitstream Charter"/>
-              </a:rPr>
-              <a:t>uname -a</a:t>
-            </a:r>
           </a:p>
           <a:p xmlns:a="http://schemas.openxmlformats.org/drawingml/2006/main">
             <a:pPr>
@@ -8388,17 +8189,6 @@
                 <a:cs typeface="Bitstream Charter"/>
               </a:defRPr>
             </a:pPr>
-            <a:r>
-              <a:rPr sz="1650" b="0">
-                <a:solidFill>
-                  <a:srgbClr val="EAF2FF"/>
-                </a:solidFill>
-                <a:latin typeface="Bitstream Charter"/>
-                <a:ea typeface="Bitstream Charter"/>
-                <a:cs typeface="Bitstream Charter"/>
-              </a:rPr>
-              <a:t>auditd EXECVE</a:t>
-            </a:r>
           </a:p>
           <a:p xmlns:a="http://schemas.openxmlformats.org/drawingml/2006/main">
             <a:pPr>
@@ -8411,17 +8201,6 @@
                 <a:cs typeface="Bitstream Charter"/>
               </a:defRPr>
             </a:pPr>
-            <a:r>
-              <a:rPr sz="1650" b="0">
-                <a:solidFill>
-                  <a:srgbClr val="EAF2FF"/>
-                </a:solidFill>
-                <a:latin typeface="Bitstream Charter"/>
-                <a:ea typeface="Bitstream Charter"/>
-                <a:cs typeface="Bitstream Charter"/>
-              </a:rPr>
-              <a:t>règle 100104</a:t>
-            </a:r>
           </a:p>
         </p:txBody>
       </p:sp>
@@ -8483,7 +8262,9 @@
                 <a:ea typeface="Bitstream Charter"/>
                 <a:cs typeface="Bitstream Charter"/>
               </a:rPr>
-              <a:t>T1057 Linux</a:t>
+              <a:t>Latence auditd → Wazuh
+P50 0,874 s · P95 1,178 s
+n = 15 ; résultat exploratoire</a:t>
             </a:r>
           </a:p>
           <a:p xmlns:a="http://schemas.openxmlformats.org/drawingml/2006/main">
@@ -8497,17 +8278,6 @@
                 <a:cs typeface="Bitstream Charter"/>
               </a:defRPr>
             </a:pPr>
-            <a:r>
-              <a:rPr sz="1650" b="0">
-                <a:solidFill>
-                  <a:srgbClr val="EAF2FF"/>
-                </a:solidFill>
-                <a:latin typeface="Bitstream Charter"/>
-                <a:ea typeface="Bitstream Charter"/>
-                <a:cs typeface="Bitstream Charter"/>
-              </a:rPr>
-              <a:t>ps -ef</a:t>
-            </a:r>
           </a:p>
           <a:p xmlns:a="http://schemas.openxmlformats.org/drawingml/2006/main">
             <a:pPr>
@@ -8520,17 +8290,6 @@
                 <a:cs typeface="Bitstream Charter"/>
               </a:defRPr>
             </a:pPr>
-            <a:r>
-              <a:rPr sz="1650" b="0">
-                <a:solidFill>
-                  <a:srgbClr val="EAF2FF"/>
-                </a:solidFill>
-                <a:latin typeface="Bitstream Charter"/>
-                <a:ea typeface="Bitstream Charter"/>
-                <a:cs typeface="Bitstream Charter"/>
-              </a:rPr>
-              <a:t>auditd EXECVE</a:t>
-            </a:r>
           </a:p>
           <a:p xmlns:a="http://schemas.openxmlformats.org/drawingml/2006/main">
             <a:pPr>
@@ -8543,17 +8302,6 @@
                 <a:cs typeface="Bitstream Charter"/>
               </a:defRPr>
             </a:pPr>
-            <a:r>
-              <a:rPr sz="1650" b="0">
-                <a:solidFill>
-                  <a:srgbClr val="EAF2FF"/>
-                </a:solidFill>
-                <a:latin typeface="Bitstream Charter"/>
-                <a:ea typeface="Bitstream Charter"/>
-                <a:cs typeface="Bitstream Charter"/>
-              </a:rPr>
-              <a:t>règle 100105</a:t>
-            </a:r>
           </a:p>
         </p:txBody>
       </p:sp>
@@ -8615,7 +8363,9 @@
                 <a:ea typeface="Bitstream Charter"/>
                 <a:cs typeface="Bitstream Charter"/>
               </a:rPr>
-              <a:t>Atomic T1057</a:t>
+              <a:t>Corrélation automatique
+Règle Wazuh 100112
+Fenêtre observée : 86 s</a:t>
             </a:r>
           </a:p>
           <a:p xmlns:a="http://schemas.openxmlformats.org/drawingml/2006/main">
@@ -8629,17 +8379,6 @@
                 <a:cs typeface="Bitstream Charter"/>
               </a:defRPr>
             </a:pPr>
-            <a:r>
-              <a:rPr sz="1575" b="0">
-                <a:solidFill>
-                  <a:srgbClr val="EAF2FF"/>
-                </a:solidFill>
-                <a:latin typeface="Bitstream Charter"/>
-                <a:ea typeface="Bitstream Charter"/>
-                <a:cs typeface="Bitstream Charter"/>
-              </a:rPr>
-              <a:t>ps et ps aux</a:t>
-            </a:r>
           </a:p>
           <a:p xmlns:a="http://schemas.openxmlformats.org/drawingml/2006/main">
             <a:pPr>
@@ -8652,17 +8391,6 @@
                 <a:cs typeface="Bitstream Charter"/>
               </a:defRPr>
             </a:pPr>
-            <a:r>
-              <a:rPr sz="1575" b="0">
-                <a:solidFill>
-                  <a:srgbClr val="EAF2FF"/>
-                </a:solidFill>
-                <a:latin typeface="Bitstream Charter"/>
-                <a:ea typeface="Bitstream Charter"/>
-                <a:cs typeface="Bitstream Charter"/>
-              </a:rPr>
-              <a:t>100105 + 92604</a:t>
-            </a:r>
           </a:p>
           <a:p xmlns:a="http://schemas.openxmlformats.org/drawingml/2006/main">
             <a:pPr>
@@ -8675,17 +8403,6 @@
                 <a:cs typeface="Bitstream Charter"/>
               </a:defRPr>
             </a:pPr>
-            <a:r>
-              <a:rPr sz="1575" b="0">
-                <a:solidFill>
-                  <a:srgbClr val="EAF2FF"/>
-                </a:solidFill>
-                <a:latin typeface="Bitstream Charter"/>
-                <a:ea typeface="Bitstream Charter"/>
-                <a:cs typeface="Bitstream Charter"/>
-              </a:rPr>
-              <a:t>nettoyage validé</a:t>
-            </a:r>
           </a:p>
         </p:txBody>
       </p:sp>
@@ -8741,7 +8458,7 @@
                 <a:ea typeface="Bitstream Charter"/>
                 <a:cs typeface="Bitstream Charter"/>
               </a:rPr>
-              <a:t>Persistance Linux validée après redémarrage : service purplewatch-sandcat actif, Caldera success à 12:33:09, Wazuh 100105 à 12:33:35.</a:t>
+              <a:t>Alerte 100112 à 13:06:04.374 (UTC+2) ; agent source 002. Mesure auditd → alerte, hors délai d’affichage du Dashboard.</a:t>
             </a:r>
           </a:p>
         </p:txBody>

</xml_diff>

<commit_message>
docs(PW-402): update final architecture slide
</commit_message>
<xml_diff>
--- a/presentation/purplewatch-soutenance-20min.pptx
+++ b/presentation/purplewatch-soutenance-20min.pptx
@@ -2199,7 +2199,7 @@
                 <a:ea typeface="Bitstream Charter"/>
                 <a:cs typeface="Bitstream Charter"/>
               </a:rPr>
-              <a:t>Projet Cybersecurity Portfolio  |  19 septembre 2026</a:t>
+              <a:t>Projet Cybersecurity Portfolio  |  24 septembre 2026</a:t>
             </a:r>
           </a:p>
         </p:txBody>
@@ -4175,7 +4175,8 @@
                 <a:ea typeface="Bitstream Charter"/>
                 <a:cs typeface="Bitstream Charter"/>
               </a:rPr>
-              <a:t>Question posée</a:t>
+              <a:t>Question posée
+Les actions contrôlées du lab génèrent-elles la télémétrie et les alertes attendues ?</a:t>
             </a:r>
           </a:p>
           <a:p xmlns:a="http://schemas.openxmlformats.org/drawingml/2006/main">
@@ -4189,17 +4190,6 @@
                 <a:cs typeface="Bitstream Charter"/>
               </a:defRPr>
             </a:pPr>
-            <a:r>
-              <a:rPr sz="1800" b="0">
-                <a:solidFill>
-                  <a:srgbClr val="EAF2FF"/>
-                </a:solidFill>
-                <a:latin typeface="Bitstream Charter"/>
-                <a:ea typeface="Bitstream Charter"/>
-                <a:cs typeface="Bitstream Charter"/>
-              </a:rPr>
-              <a:t>Les techniques de découverte exécutées dans le laboratoire génèrent-elles une alerte Wazuh exploitable ?</a:t>
-            </a:r>
           </a:p>
         </p:txBody>
       </p:sp>
@@ -4663,7 +4653,8 @@
                 <a:ea typeface="Bitstream Charter"/>
                 <a:cs typeface="Bitstream Charter"/>
               </a:rPr>
-              <a:t>Techniques limitées</a:t>
+              <a:t>Techniques limitées
+Exécution, découverte, lecture de leurre, collecte fictive et camouflage inoffensif.</a:t>
             </a:r>
           </a:p>
           <a:p xmlns:a="http://schemas.openxmlformats.org/drawingml/2006/main">
@@ -4677,17 +4668,6 @@
                 <a:cs typeface="Bitstream Charter"/>
               </a:defRPr>
             </a:pPr>
-            <a:r>
-              <a:rPr sz="1650" b="0">
-                <a:solidFill>
-                  <a:srgbClr val="EAF2FF"/>
-                </a:solidFill>
-                <a:latin typeface="Bitstream Charter"/>
-                <a:ea typeface="Bitstream Charter"/>
-                <a:cs typeface="Bitstream Charter"/>
-              </a:rPr>
-              <a:t>Découverte système, processus, comptes et réseau. Aucun scénario destructif.</a:t>
-            </a:r>
           </a:p>
         </p:txBody>
       </p:sp>
@@ -5064,415 +5044,719 @@
           </a:p>
         </p:txBody>
       </p:sp>
-      <p:sp>
-        <p:nvSpPr>
-          <p:cNvPr id="5" name="">
-            <a:extLst xmlns:a="http://schemas.openxmlformats.org/drawingml/2006/main">
-              <a:ext uri="{FF2B5EF4-FFF2-40B4-BE49-F238E27FC236}">
-                <a16:creationId xmlns:a16="http://schemas.microsoft.com/office/drawing/2014/main" id="{D7213F22-0F50-4F38-9F93-CD5A24E55B97}"/>
-              </a:ext>
-            </a:extLst>
-          </p:cNvPr>
-          <p:cNvSpPr>
-            <a:spLocks xmlns:a="http://schemas.openxmlformats.org/drawingml/2006/main" noGrp="1"/>
-          </p:cNvSpPr>
-          <p:nvPr/>
-        </p:nvSpPr>
-        <p:spPr>
-          <a:xfrm xmlns:a="http://schemas.openxmlformats.org/drawingml/2006/main">
-            <a:off x="762000" y="1762125"/>
-            <a:ext cx="2286000" cy="1619250"/>
-          </a:xfrm>
-          <a:prstGeom xmlns:a="http://schemas.openxmlformats.org/drawingml/2006/main" prst="roundRect">
-            <a:avLst>
-              <a:gd name="adj" fmla="val 4706"/>
-            </a:avLst>
-          </a:prstGeom>
-          <a:solidFill xmlns:a="http://schemas.openxmlformats.org/drawingml/2006/main">
-            <a:srgbClr val="153B66"/>
+      <p:sp xmlns:a="http://schemas.openxmlformats.org/drawingml/2006/main">
+        <p:nvSpPr>
+          <p:cNvPr id="11" name="Rounded Rectangle 10"/>
+          <p:cNvSpPr/>
+          <p:nvPr/>
+        </p:nvSpPr>
+        <p:spPr>
+          <a:xfrm>
+            <a:off x="731520" y="1554480"/>
+            <a:ext cx="5303520" cy="4370832"/>
+          </a:xfrm>
+          <a:prstGeom prst="roundRect">
+            <a:avLst/>
+          </a:prstGeom>
+          <a:solidFill>
+            <a:srgbClr val="102336"/>
           </a:solidFill>
-          <a:ln xmlns:a="http://schemas.openxmlformats.org/drawingml/2006/main" w="14288">
+          <a:ln>
             <a:solidFill>
-              <a:srgbClr val="A855F7"/>
+              <a:srgbClr val="A26DF4"/>
             </a:solidFill>
           </a:ln>
         </p:spPr>
-        <p:txBody>
-          <a:bodyPr xmlns:a="http://schemas.openxmlformats.org/drawingml/2006/main">
-            <a:normAutofit fontScale="100000"/>
+        <p:style>
+          <a:lnRef idx="1">
+            <a:schemeClr val="accent1"/>
+          </a:lnRef>
+          <a:fillRef idx="3">
+            <a:schemeClr val="accent1"/>
+          </a:fillRef>
+          <a:effectRef idx="2">
+            <a:schemeClr val="accent1"/>
+          </a:effectRef>
+          <a:fontRef idx="minor">
+            <a:schemeClr val="lt1"/>
+          </a:fontRef>
+        </p:style>
+        <p:txBody>
+          <a:bodyPr rtlCol="0" anchor="ctr" wrap="square" lIns="109728" rIns="109728" tIns="54864" bIns="54864"/>
+          <a:lstStyle/>
+          <a:p>
+            <a:pPr algn="ctr"/>
+            <a:r>
+              <a:rPr sz="1200" b="0">
+                <a:solidFill>
+                  <a:srgbClr val="F6F9FF"/>
+                </a:solidFill>
+                <a:latin typeface="Aptos"/>
+              </a:rPr>
+              <a:t/>
+            </a:r>
+          </a:p>
+        </p:txBody>
+      </p:sp>
+      <p:sp xmlns:a="http://schemas.openxmlformats.org/drawingml/2006/main">
+        <p:nvSpPr>
+          <p:cNvPr id="12" name="Rounded Rectangle 11"/>
+          <p:cNvSpPr/>
+          <p:nvPr/>
+        </p:nvSpPr>
+        <p:spPr>
+          <a:xfrm>
+            <a:off x="6172200" y="1554480"/>
+            <a:ext cx="5303520" cy="4370832"/>
+          </a:xfrm>
+          <a:prstGeom prst="roundRect">
+            <a:avLst/>
+          </a:prstGeom>
+          <a:solidFill>
+            <a:srgbClr val="102336"/>
+          </a:solidFill>
+          <a:ln>
+            <a:solidFill>
+              <a:srgbClr val="45B6E5"/>
+            </a:solidFill>
+          </a:ln>
+        </p:spPr>
+        <p:style>
+          <a:lnRef idx="1">
+            <a:schemeClr val="accent1"/>
+          </a:lnRef>
+          <a:fillRef idx="3">
+            <a:schemeClr val="accent1"/>
+          </a:fillRef>
+          <a:effectRef idx="2">
+            <a:schemeClr val="accent1"/>
+          </a:effectRef>
+          <a:fontRef idx="minor">
+            <a:schemeClr val="lt1"/>
+          </a:fontRef>
+        </p:style>
+        <p:txBody>
+          <a:bodyPr rtlCol="0" anchor="ctr" wrap="square" lIns="109728" rIns="109728" tIns="54864" bIns="54864"/>
+          <a:lstStyle/>
+          <a:p>
+            <a:pPr algn="ctr"/>
+            <a:r>
+              <a:rPr sz="1200" b="0">
+                <a:solidFill>
+                  <a:srgbClr val="F6F9FF"/>
+                </a:solidFill>
+                <a:latin typeface="Aptos"/>
+              </a:rPr>
+              <a:t/>
+            </a:r>
+          </a:p>
+        </p:txBody>
+      </p:sp>
+      <p:sp xmlns:a="http://schemas.openxmlformats.org/drawingml/2006/main">
+        <p:nvSpPr>
+          <p:cNvPr id="13" name="TextBox 12"/>
+          <p:cNvSpPr txBox="1"/>
+          <p:nvPr/>
+        </p:nvSpPr>
+        <p:spPr>
+          <a:xfrm>
+            <a:off x="914400" y="1709928"/>
+            <a:ext cx="4937760" cy="301752"/>
+          </a:xfrm>
+          <a:prstGeom prst="rect">
+            <a:avLst/>
+          </a:prstGeom>
+          <a:noFill/>
+        </p:spPr>
+        <p:txBody>
+          <a:bodyPr wrap="none" lIns="0" rIns="0">
+            <a:spAutoFit/>
           </a:bodyPr>
-          <a:lstStyle xmlns:a="http://schemas.openxmlformats.org/drawingml/2006/main"/>
-          <a:p xmlns:a="http://schemas.openxmlformats.org/drawingml/2006/main">
-            <a:pPr>
-              <a:defRPr sz="1500" b="0">
-                <a:solidFill>
-                  <a:srgbClr val="EAF2FF"/>
-                </a:solidFill>
-                <a:latin typeface="Bitstream Charter"/>
-                <a:ea typeface="Bitstream Charter"/>
-                <a:cs typeface="Bitstream Charter"/>
-              </a:defRPr>
-            </a:pPr>
+          <a:lstStyle/>
+          <a:p>
+            <a:pPr algn="ctr"/>
+            <a:r>
+              <a:rPr sz="1700">
+                <a:solidFill>
+                  <a:srgbClr val="C4A0FA"/>
+                </a:solidFill>
+                <a:latin typeface="Aptos"/>
+              </a:rPr>
+              <a:t>CLOUD SCALEWAY</a:t>
+            </a:r>
+          </a:p>
+        </p:txBody>
+      </p:sp>
+      <p:sp xmlns:a="http://schemas.openxmlformats.org/drawingml/2006/main">
+        <p:nvSpPr>
+          <p:cNvPr id="14" name="TextBox 13"/>
+          <p:cNvSpPr txBox="1"/>
+          <p:nvPr/>
+        </p:nvSpPr>
+        <p:spPr>
+          <a:xfrm>
+            <a:off x="6355080" y="1709928"/>
+            <a:ext cx="4937760" cy="301752"/>
+          </a:xfrm>
+          <a:prstGeom prst="rect">
+            <a:avLst/>
+          </a:prstGeom>
+          <a:noFill/>
+        </p:spPr>
+        <p:txBody>
+          <a:bodyPr wrap="none" lIns="0" rIns="0">
+            <a:spAutoFit/>
+          </a:bodyPr>
+          <a:lstStyle/>
+          <a:p>
+            <a:pPr algn="ctr"/>
+            <a:r>
+              <a:rPr sz="1700">
+                <a:solidFill>
+                  <a:srgbClr val="69D5F5"/>
+                </a:solidFill>
+                <a:latin typeface="Aptos"/>
+              </a:rPr>
+              <a:t>LOCAL VIRTUALBOX + POSTE HÔTE</a:t>
+            </a:r>
+          </a:p>
+        </p:txBody>
+      </p:sp>
+      <p:sp xmlns:a="http://schemas.openxmlformats.org/drawingml/2006/main">
+        <p:nvSpPr>
+          <p:cNvPr id="15" name="Rounded Rectangle 14"/>
+          <p:cNvSpPr/>
+          <p:nvPr/>
+        </p:nvSpPr>
+        <p:spPr>
+          <a:xfrm>
+            <a:off x="978408" y="2258568"/>
+            <a:ext cx="2139696" cy="1033271"/>
+          </a:xfrm>
+          <a:prstGeom prst="roundRect">
+            <a:avLst/>
+          </a:prstGeom>
+          <a:solidFill>
+            <a:srgbClr val="1D3D5F"/>
+          </a:solidFill>
+          <a:ln>
+            <a:solidFill>
+              <a:srgbClr val="AC7BFB"/>
+            </a:solidFill>
+          </a:ln>
+        </p:spPr>
+        <p:style>
+          <a:lnRef idx="1">
+            <a:schemeClr val="accent1"/>
+          </a:lnRef>
+          <a:fillRef idx="3">
+            <a:schemeClr val="accent1"/>
+          </a:fillRef>
+          <a:effectRef idx="2">
+            <a:schemeClr val="accent1"/>
+          </a:effectRef>
+          <a:fontRef idx="minor">
+            <a:schemeClr val="lt1"/>
+          </a:fontRef>
+        </p:style>
+        <p:txBody>
+          <a:bodyPr rtlCol="0" anchor="ctr" wrap="square" lIns="109728" rIns="109728" tIns="54864" bIns="54864"/>
+          <a:lstStyle/>
+          <a:p>
+            <a:pPr algn="ctr"/>
             <a:r>
               <a:rPr sz="1500" b="0">
                 <a:solidFill>
-                  <a:srgbClr val="EAF2FF"/>
-                </a:solidFill>
-                <a:latin typeface="Bitstream Charter"/>
-                <a:ea typeface="Bitstream Charter"/>
-                <a:cs typeface="Bitstream Charter"/>
-              </a:rPr>
-              <a:t>PW-CALDERA-01 · Scaleway
-Caldera, orchestration
-Tailscale · HTTP 8888</a:t>
-            </a:r>
-          </a:p>
-          <a:p xmlns:a="http://schemas.openxmlformats.org/drawingml/2006/main">
-            <a:pPr>
-              <a:defRPr sz="1500" b="0">
-                <a:solidFill>
-                  <a:srgbClr val="EAF2FF"/>
-                </a:solidFill>
-                <a:latin typeface="Bitstream Charter"/>
-                <a:ea typeface="Bitstream Charter"/>
-                <a:cs typeface="Bitstream Charter"/>
-              </a:defRPr>
-            </a:pPr>
-          </a:p>
-          <a:p xmlns:a="http://schemas.openxmlformats.org/drawingml/2006/main">
-            <a:pPr>
-              <a:defRPr sz="1500" b="0">
-                <a:solidFill>
-                  <a:srgbClr val="EAF2FF"/>
-                </a:solidFill>
-                <a:latin typeface="Bitstream Charter"/>
-                <a:ea typeface="Bitstream Charter"/>
-                <a:cs typeface="Bitstream Charter"/>
-              </a:defRPr>
-            </a:pPr>
-          </a:p>
-        </p:txBody>
-      </p:sp>
-      <p:sp>
-        <p:nvSpPr>
-          <p:cNvPr id="6" name="">
-            <a:extLst xmlns:a="http://schemas.openxmlformats.org/drawingml/2006/main">
-              <a:ext uri="{FF2B5EF4-FFF2-40B4-BE49-F238E27FC236}">
-                <a16:creationId xmlns:a16="http://schemas.microsoft.com/office/drawing/2014/main" id="{9B47E2C7-8900-4882-8305-2813AC00ECC6}"/>
-              </a:ext>
-            </a:extLst>
-          </p:cNvPr>
-          <p:cNvSpPr>
-            <a:spLocks xmlns:a="http://schemas.openxmlformats.org/drawingml/2006/main" noGrp="1"/>
-          </p:cNvSpPr>
-          <p:nvPr/>
-        </p:nvSpPr>
-        <p:spPr>
-          <a:xfrm xmlns:a="http://schemas.openxmlformats.org/drawingml/2006/main">
-            <a:off x="3476625" y="1762125"/>
-            <a:ext cx="2286000" cy="1619250"/>
-          </a:xfrm>
-          <a:prstGeom xmlns:a="http://schemas.openxmlformats.org/drawingml/2006/main" prst="roundRect">
-            <a:avLst>
-              <a:gd name="adj" fmla="val 4706"/>
-            </a:avLst>
-          </a:prstGeom>
-          <a:solidFill xmlns:a="http://schemas.openxmlformats.org/drawingml/2006/main">
-            <a:srgbClr val="153B66"/>
+                  <a:srgbClr val="F6F9FF"/>
+                </a:solidFill>
+                <a:latin typeface="Aptos"/>
+              </a:rPr>
+              <a:t>PW-CALDERA-01
+Caldera · C2 Sandcat</a:t>
+            </a:r>
+          </a:p>
+        </p:txBody>
+      </p:sp>
+      <p:sp xmlns:a="http://schemas.openxmlformats.org/drawingml/2006/main">
+        <p:nvSpPr>
+          <p:cNvPr id="16" name="Rounded Rectangle 15"/>
+          <p:cNvSpPr/>
+          <p:nvPr/>
+        </p:nvSpPr>
+        <p:spPr>
+          <a:xfrm>
+            <a:off x="3584448" y="2258568"/>
+            <a:ext cx="2139696" cy="1033271"/>
+          </a:xfrm>
+          <a:prstGeom prst="roundRect">
+            <a:avLst/>
+          </a:prstGeom>
+          <a:solidFill>
+            <a:srgbClr val="1D3D5F"/>
           </a:solidFill>
-          <a:ln xmlns:a="http://schemas.openxmlformats.org/drawingml/2006/main" w="14288">
+          <a:ln>
             <a:solidFill>
-              <a:srgbClr val="38BDF8"/>
+              <a:srgbClr val="4ADAAD"/>
             </a:solidFill>
           </a:ln>
         </p:spPr>
-        <p:txBody>
-          <a:bodyPr xmlns:a="http://schemas.openxmlformats.org/drawingml/2006/main">
-            <a:normAutofit fontScale="100000"/>
+        <p:style>
+          <a:lnRef idx="1">
+            <a:schemeClr val="accent1"/>
+          </a:lnRef>
+          <a:fillRef idx="3">
+            <a:schemeClr val="accent1"/>
+          </a:fillRef>
+          <a:effectRef idx="2">
+            <a:schemeClr val="accent1"/>
+          </a:effectRef>
+          <a:fontRef idx="minor">
+            <a:schemeClr val="lt1"/>
+          </a:fontRef>
+        </p:style>
+        <p:txBody>
+          <a:bodyPr rtlCol="0" anchor="ctr" wrap="square" lIns="109728" rIns="109728" tIns="54864" bIns="54864"/>
+          <a:lstStyle/>
+          <a:p>
+            <a:pPr algn="ctr"/>
+            <a:r>
+              <a:rPr sz="1500" b="0">
+                <a:solidFill>
+                  <a:srgbClr val="F6F9FF"/>
+                </a:solidFill>
+                <a:latin typeface="Aptos"/>
+              </a:rPr>
+              <a:t>PW-LINUX-01
+Sandcat · auditd · agent</a:t>
+            </a:r>
+          </a:p>
+        </p:txBody>
+      </p:sp>
+      <p:sp xmlns:a="http://schemas.openxmlformats.org/drawingml/2006/main">
+        <p:nvSpPr>
+          <p:cNvPr id="17" name="Rounded Rectangle 16"/>
+          <p:cNvSpPr/>
+          <p:nvPr/>
+        </p:nvSpPr>
+        <p:spPr>
+          <a:xfrm>
+            <a:off x="6428232" y="2258568"/>
+            <a:ext cx="2139696" cy="1033271"/>
+          </a:xfrm>
+          <a:prstGeom prst="roundRect">
+            <a:avLst/>
+          </a:prstGeom>
+          <a:solidFill>
+            <a:srgbClr val="1D3D5F"/>
+          </a:solidFill>
+          <a:ln>
+            <a:solidFill>
+              <a:srgbClr val="45B6E5"/>
+            </a:solidFill>
+          </a:ln>
+        </p:spPr>
+        <p:style>
+          <a:lnRef idx="1">
+            <a:schemeClr val="accent1"/>
+          </a:lnRef>
+          <a:fillRef idx="3">
+            <a:schemeClr val="accent1"/>
+          </a:fillRef>
+          <a:effectRef idx="2">
+            <a:schemeClr val="accent1"/>
+          </a:effectRef>
+          <a:fontRef idx="minor">
+            <a:schemeClr val="lt1"/>
+          </a:fontRef>
+        </p:style>
+        <p:txBody>
+          <a:bodyPr rtlCol="0" anchor="ctr" wrap="square" lIns="109728" rIns="109728" tIns="54864" bIns="54864"/>
+          <a:lstStyle/>
+          <a:p>
+            <a:pPr algn="ctr"/>
+            <a:r>
+              <a:rPr sz="1500" b="0">
+                <a:solidFill>
+                  <a:srgbClr val="F6F9FF"/>
+                </a:solidFill>
+                <a:latin typeface="Aptos"/>
+              </a:rPr>
+              <a:t>PW-WIN11-01
+Sandcat · Sysmon · agent</a:t>
+            </a:r>
+          </a:p>
+        </p:txBody>
+      </p:sp>
+      <p:sp xmlns:a="http://schemas.openxmlformats.org/drawingml/2006/main">
+        <p:nvSpPr>
+          <p:cNvPr id="18" name="Rounded Rectangle 17"/>
+          <p:cNvSpPr/>
+          <p:nvPr/>
+        </p:nvSpPr>
+        <p:spPr>
+          <a:xfrm>
+            <a:off x="9043416" y="2258568"/>
+            <a:ext cx="2139696" cy="1033271"/>
+          </a:xfrm>
+          <a:prstGeom prst="roundRect">
+            <a:avLst/>
+          </a:prstGeom>
+          <a:solidFill>
+            <a:srgbClr val="1D3D5F"/>
+          </a:solidFill>
+          <a:ln>
+            <a:solidFill>
+              <a:srgbClr val="45B6E5"/>
+            </a:solidFill>
+          </a:ln>
+        </p:spPr>
+        <p:style>
+          <a:lnRef idx="1">
+            <a:schemeClr val="accent1"/>
+          </a:lnRef>
+          <a:fillRef idx="3">
+            <a:schemeClr val="accent1"/>
+          </a:fillRef>
+          <a:effectRef idx="2">
+            <a:schemeClr val="accent1"/>
+          </a:effectRef>
+          <a:fontRef idx="minor">
+            <a:schemeClr val="lt1"/>
+          </a:fontRef>
+        </p:style>
+        <p:txBody>
+          <a:bodyPr rtlCol="0" anchor="ctr" wrap="square" lIns="109728" rIns="109728" tIns="54864" bIns="54864"/>
+          <a:lstStyle/>
+          <a:p>
+            <a:pPr algn="ctr"/>
+            <a:r>
+              <a:rPr sz="1500" b="0">
+                <a:solidFill>
+                  <a:srgbClr val="F6F9FF"/>
+                </a:solidFill>
+                <a:latin typeface="Aptos"/>
+              </a:rPr>
+              <a:t>PW-WAZUH-01
+Manager · Indexer · UI</a:t>
+            </a:r>
+          </a:p>
+        </p:txBody>
+      </p:sp>
+      <p:cxnSp xmlns:a="http://schemas.openxmlformats.org/drawingml/2006/main">
+        <p:nvCxnSpPr>
+          <p:cNvPr id="19" name="Connector 18"/>
+          <p:cNvCxnSpPr/>
+          <p:nvPr/>
+        </p:nvCxnSpPr>
+        <p:spPr>
+          <a:xfrm>
+            <a:off x="3127248" y="2770632"/>
+            <a:ext cx="429768" cy="0"/>
+          </a:xfrm>
+          <a:prstGeom prst="line">
+            <a:avLst/>
+          </a:prstGeom>
+          <a:ln w="25400">
+            <a:solidFill>
+              <a:srgbClr val="AC7BFB"/>
+            </a:solidFill>
+            <a:tailEnd type="triangle"/>
+          </a:ln>
+        </p:spPr>
+        <p:style>
+          <a:lnRef idx="2">
+            <a:schemeClr val="accent1"/>
+          </a:lnRef>
+          <a:fillRef idx="0">
+            <a:schemeClr val="accent1"/>
+          </a:fillRef>
+          <a:effectRef idx="1">
+            <a:schemeClr val="accent1"/>
+          </a:effectRef>
+          <a:fontRef idx="minor">
+            <a:schemeClr val="tx1"/>
+          </a:fontRef>
+        </p:style>
+      </p:cxnSp>
+      <p:sp xmlns:a="http://schemas.openxmlformats.org/drawingml/2006/main">
+        <p:nvSpPr>
+          <p:cNvPr id="20" name="TextBox 19"/>
+          <p:cNvSpPr txBox="1"/>
+          <p:nvPr/>
+        </p:nvSpPr>
+        <p:spPr>
+          <a:xfrm>
+            <a:off x="3118104" y="2953512"/>
+            <a:ext cx="457200" cy="301752"/>
+          </a:xfrm>
+          <a:prstGeom prst="rect">
+            <a:avLst/>
+          </a:prstGeom>
+          <a:noFill/>
+        </p:spPr>
+        <p:txBody>
+          <a:bodyPr wrap="none" lIns="0" rIns="0">
+            <a:spAutoFit/>
           </a:bodyPr>
-          <a:lstStyle xmlns:a="http://schemas.openxmlformats.org/drawingml/2006/main"/>
-          <a:p xmlns:a="http://schemas.openxmlformats.org/drawingml/2006/main">
-            <a:pPr>
-              <a:defRPr sz="1500" b="0">
-                <a:solidFill>
-                  <a:srgbClr val="EAF2FF"/>
-                </a:solidFill>
-                <a:latin typeface="Bitstream Charter"/>
-                <a:ea typeface="Bitstream Charter"/>
-                <a:cs typeface="Bitstream Charter"/>
-              </a:defRPr>
-            </a:pPr>
-            <a:r>
-              <a:rPr sz="1500" b="0">
-                <a:solidFill>
-                  <a:srgbClr val="EAF2FF"/>
-                </a:solidFill>
-                <a:latin typeface="Bitstream Charter"/>
-                <a:ea typeface="Bitstream Charter"/>
-                <a:cs typeface="Bitstream Charter"/>
-              </a:rPr>
-              <a:t>PW-WIN11-01 · VirtualBox
-Sandcat, Sysmon
-Agent Wazuh</a:t>
-            </a:r>
-          </a:p>
-          <a:p xmlns:a="http://schemas.openxmlformats.org/drawingml/2006/main">
-            <a:pPr>
-              <a:defRPr sz="1500" b="0">
-                <a:solidFill>
-                  <a:srgbClr val="EAF2FF"/>
-                </a:solidFill>
-                <a:latin typeface="Bitstream Charter"/>
-                <a:ea typeface="Bitstream Charter"/>
-                <a:cs typeface="Bitstream Charter"/>
-              </a:defRPr>
-            </a:pPr>
-          </a:p>
-          <a:p xmlns:a="http://schemas.openxmlformats.org/drawingml/2006/main">
-            <a:pPr>
-              <a:defRPr sz="1500" b="0">
-                <a:solidFill>
-                  <a:srgbClr val="EAF2FF"/>
-                </a:solidFill>
-                <a:latin typeface="Bitstream Charter"/>
-                <a:ea typeface="Bitstream Charter"/>
-                <a:cs typeface="Bitstream Charter"/>
-              </a:defRPr>
-            </a:pPr>
-          </a:p>
-        </p:txBody>
-      </p:sp>
-      <p:sp>
-        <p:nvSpPr>
-          <p:cNvPr id="7" name="">
-            <a:extLst xmlns:a="http://schemas.openxmlformats.org/drawingml/2006/main">
-              <a:ext uri="{FF2B5EF4-FFF2-40B4-BE49-F238E27FC236}">
-                <a16:creationId xmlns:a16="http://schemas.microsoft.com/office/drawing/2014/main" id="{96496C0C-4C0F-465C-AF1D-80C3A87678C2}"/>
-              </a:ext>
-            </a:extLst>
-          </p:cNvPr>
-          <p:cNvSpPr>
-            <a:spLocks xmlns:a="http://schemas.openxmlformats.org/drawingml/2006/main" noGrp="1"/>
-          </p:cNvSpPr>
-          <p:nvPr/>
-        </p:nvSpPr>
-        <p:spPr>
-          <a:xfrm xmlns:a="http://schemas.openxmlformats.org/drawingml/2006/main">
-            <a:off x="6191250" y="1762125"/>
-            <a:ext cx="2286000" cy="1619250"/>
-          </a:xfrm>
-          <a:prstGeom xmlns:a="http://schemas.openxmlformats.org/drawingml/2006/main" prst="roundRect">
-            <a:avLst>
-              <a:gd name="adj" fmla="val 4706"/>
-            </a:avLst>
-          </a:prstGeom>
-          <a:solidFill xmlns:a="http://schemas.openxmlformats.org/drawingml/2006/main">
-            <a:srgbClr val="153B66"/>
-          </a:solidFill>
-          <a:ln xmlns:a="http://schemas.openxmlformats.org/drawingml/2006/main" w="14288">
+          <a:lstStyle/>
+          <a:p>
+            <a:pPr algn="ctr"/>
+            <a:r>
+              <a:rPr sz="1000">
+                <a:solidFill>
+                  <a:srgbClr val="C4A0FA"/>
+                </a:solidFill>
+                <a:latin typeface="Aptos"/>
+              </a:rPr>
+              <a:t>8888</a:t>
+            </a:r>
+          </a:p>
+        </p:txBody>
+      </p:sp>
+      <p:cxnSp xmlns:a="http://schemas.openxmlformats.org/drawingml/2006/main">
+        <p:nvCxnSpPr>
+          <p:cNvPr id="21" name="Connector 20"/>
+          <p:cNvCxnSpPr/>
+          <p:nvPr/>
+        </p:nvCxnSpPr>
+        <p:spPr>
+          <a:xfrm>
+            <a:off x="6949440" y="3474720"/>
+            <a:ext cx="3154680" cy="0"/>
+          </a:xfrm>
+          <a:prstGeom prst="line">
+            <a:avLst/>
+          </a:prstGeom>
+          <a:ln w="25400">
             <a:solidFill>
-              <a:srgbClr val="44D19D"/>
+              <a:srgbClr val="45B6E5"/>
             </a:solidFill>
-          </a:ln>
-        </p:spPr>
-        <p:txBody>
-          <a:bodyPr xmlns:a="http://schemas.openxmlformats.org/drawingml/2006/main">
-            <a:normAutofit fontScale="100000"/>
+            <a:tailEnd type="triangle"/>
+          </a:ln>
+        </p:spPr>
+        <p:style>
+          <a:lnRef idx="2">
+            <a:schemeClr val="accent1"/>
+          </a:lnRef>
+          <a:fillRef idx="0">
+            <a:schemeClr val="accent1"/>
+          </a:fillRef>
+          <a:effectRef idx="1">
+            <a:schemeClr val="accent1"/>
+          </a:effectRef>
+          <a:fontRef idx="minor">
+            <a:schemeClr val="tx1"/>
+          </a:fontRef>
+        </p:style>
+      </p:cxnSp>
+      <p:sp xmlns:a="http://schemas.openxmlformats.org/drawingml/2006/main">
+        <p:nvSpPr>
+          <p:cNvPr id="22" name="TextBox 21"/>
+          <p:cNvSpPr txBox="1"/>
+          <p:nvPr/>
+        </p:nvSpPr>
+        <p:spPr>
+          <a:xfrm>
+            <a:off x="6675120" y="3593592"/>
+            <a:ext cx="3703320" cy="301752"/>
+          </a:xfrm>
+          <a:prstGeom prst="rect">
+            <a:avLst/>
+          </a:prstGeom>
+          <a:noFill/>
+        </p:spPr>
+        <p:txBody>
+          <a:bodyPr wrap="none" lIns="0" rIns="0">
+            <a:spAutoFit/>
           </a:bodyPr>
-          <a:lstStyle xmlns:a="http://schemas.openxmlformats.org/drawingml/2006/main"/>
-          <a:p xmlns:a="http://schemas.openxmlformats.org/drawingml/2006/main">
-            <a:pPr>
-              <a:defRPr sz="1500" b="0">
-                <a:solidFill>
-                  <a:srgbClr val="EAF2FF"/>
-                </a:solidFill>
-                <a:latin typeface="Bitstream Charter"/>
-                <a:ea typeface="Bitstream Charter"/>
-                <a:cs typeface="Bitstream Charter"/>
-              </a:defRPr>
-            </a:pPr>
-            <a:r>
-              <a:rPr sz="1500" b="0">
-                <a:solidFill>
-                  <a:srgbClr val="EAF2FF"/>
-                </a:solidFill>
-                <a:latin typeface="Bitstream Charter"/>
-                <a:ea typeface="Bitstream Charter"/>
-                <a:cs typeface="Bitstream Charter"/>
-              </a:rPr>
-              <a:t>PW-LINUX-01 · Scaleway
-Sandcat, auditd
-Agent Wazuh</a:t>
-            </a:r>
-          </a:p>
-          <a:p xmlns:a="http://schemas.openxmlformats.org/drawingml/2006/main">
-            <a:pPr>
-              <a:defRPr sz="1500" b="0">
-                <a:solidFill>
-                  <a:srgbClr val="EAF2FF"/>
-                </a:solidFill>
-                <a:latin typeface="Bitstream Charter"/>
-                <a:ea typeface="Bitstream Charter"/>
-                <a:cs typeface="Bitstream Charter"/>
-              </a:defRPr>
-            </a:pPr>
-          </a:p>
-          <a:p xmlns:a="http://schemas.openxmlformats.org/drawingml/2006/main">
-            <a:pPr>
-              <a:defRPr sz="1500" b="0">
-                <a:solidFill>
-                  <a:srgbClr val="EAF2FF"/>
-                </a:solidFill>
-                <a:latin typeface="Bitstream Charter"/>
-                <a:ea typeface="Bitstream Charter"/>
-                <a:cs typeface="Bitstream Charter"/>
-              </a:defRPr>
-            </a:pPr>
-          </a:p>
-        </p:txBody>
-      </p:sp>
-      <p:sp>
-        <p:nvSpPr>
-          <p:cNvPr id="8" name="">
-            <a:extLst xmlns:a="http://schemas.openxmlformats.org/drawingml/2006/main">
-              <a:ext uri="{FF2B5EF4-FFF2-40B4-BE49-F238E27FC236}">
-                <a16:creationId xmlns:a16="http://schemas.microsoft.com/office/drawing/2014/main" id="{5D7CF989-5E1C-447F-B95B-EFC60DE5357E}"/>
-              </a:ext>
-            </a:extLst>
-          </p:cNvPr>
-          <p:cNvSpPr>
-            <a:spLocks xmlns:a="http://schemas.openxmlformats.org/drawingml/2006/main" noGrp="1"/>
-          </p:cNvSpPr>
-          <p:nvPr/>
-        </p:nvSpPr>
-        <p:spPr>
-          <a:xfrm xmlns:a="http://schemas.openxmlformats.org/drawingml/2006/main">
-            <a:off x="8905875" y="1762125"/>
-            <a:ext cx="2286000" cy="1619250"/>
-          </a:xfrm>
-          <a:prstGeom xmlns:a="http://schemas.openxmlformats.org/drawingml/2006/main" prst="roundRect">
-            <a:avLst>
-              <a:gd name="adj" fmla="val 4706"/>
-            </a:avLst>
-          </a:prstGeom>
-          <a:solidFill xmlns:a="http://schemas.openxmlformats.org/drawingml/2006/main">
-            <a:srgbClr val="153B66"/>
-          </a:solidFill>
-          <a:ln xmlns:a="http://schemas.openxmlformats.org/drawingml/2006/main" w="14288">
+          <a:lstStyle/>
+          <a:p>
+            <a:pPr algn="ctr"/>
+            <a:r>
+              <a:rPr sz="1300">
+                <a:solidFill>
+                  <a:srgbClr val="C7DCEE"/>
+                </a:solidFill>
+                <a:latin typeface="Aptos"/>
+              </a:rPr>
+              <a:t>Sysmon → Wazuh · host-only · TCP 1514</a:t>
+            </a:r>
+          </a:p>
+        </p:txBody>
+      </p:sp>
+      <p:cxnSp xmlns:a="http://schemas.openxmlformats.org/drawingml/2006/main">
+        <p:nvCxnSpPr>
+          <p:cNvPr id="23" name="Connector 22"/>
+          <p:cNvCxnSpPr/>
+          <p:nvPr/>
+        </p:nvCxnSpPr>
+        <p:spPr>
+          <a:xfrm>
+            <a:off x="2057400" y="4343400"/>
+            <a:ext cx="5422392" cy="0"/>
+          </a:xfrm>
+          <a:prstGeom prst="line">
+            <a:avLst/>
+          </a:prstGeom>
+          <a:ln w="25400">
             <a:solidFill>
-              <a:srgbClr val="38BDF8"/>
+              <a:srgbClr val="AC7BFB"/>
             </a:solidFill>
-          </a:ln>
-        </p:spPr>
-        <p:txBody>
-          <a:bodyPr xmlns:a="http://schemas.openxmlformats.org/drawingml/2006/main">
-            <a:normAutofit fontScale="100000"/>
+            <a:tailEnd type="triangle"/>
+          </a:ln>
+        </p:spPr>
+        <p:style>
+          <a:lnRef idx="2">
+            <a:schemeClr val="accent1"/>
+          </a:lnRef>
+          <a:fillRef idx="0">
+            <a:schemeClr val="accent1"/>
+          </a:fillRef>
+          <a:effectRef idx="1">
+            <a:schemeClr val="accent1"/>
+          </a:effectRef>
+          <a:fontRef idx="minor">
+            <a:schemeClr val="tx1"/>
+          </a:fontRef>
+        </p:style>
+      </p:cxnSp>
+      <p:sp xmlns:a="http://schemas.openxmlformats.org/drawingml/2006/main">
+        <p:nvSpPr>
+          <p:cNvPr id="24" name="TextBox 23"/>
+          <p:cNvSpPr txBox="1"/>
+          <p:nvPr/>
+        </p:nvSpPr>
+        <p:spPr>
+          <a:xfrm>
+            <a:off x="2057400" y="4050791"/>
+            <a:ext cx="5486400" cy="301752"/>
+          </a:xfrm>
+          <a:prstGeom prst="rect">
+            <a:avLst/>
+          </a:prstGeom>
+          <a:noFill/>
+        </p:spPr>
+        <p:txBody>
+          <a:bodyPr wrap="none" lIns="0" rIns="0">
+            <a:spAutoFit/>
           </a:bodyPr>
-          <a:lstStyle xmlns:a="http://schemas.openxmlformats.org/drawingml/2006/main"/>
-          <a:p xmlns:a="http://schemas.openxmlformats.org/drawingml/2006/main">
-            <a:pPr>
-              <a:defRPr sz="1500" b="0">
-                <a:solidFill>
-                  <a:srgbClr val="EAF2FF"/>
-                </a:solidFill>
-                <a:latin typeface="Bitstream Charter"/>
-                <a:ea typeface="Bitstream Charter"/>
-                <a:cs typeface="Bitstream Charter"/>
-              </a:defRPr>
-            </a:pPr>
-            <a:r>
-              <a:rPr sz="1500" b="0">
-                <a:solidFill>
-                  <a:srgbClr val="EAF2FF"/>
-                </a:solidFill>
-                <a:latin typeface="Bitstream Charter"/>
-                <a:ea typeface="Bitstream Charter"/>
-                <a:cs typeface="Bitstream Charter"/>
-              </a:rPr>
-              <a:t>PW-WAZUH-01 · VirtualBox
-Manager, Indexer
-Dashboard</a:t>
-            </a:r>
-          </a:p>
-          <a:p xmlns:a="http://schemas.openxmlformats.org/drawingml/2006/main">
-            <a:pPr>
-              <a:defRPr sz="1500" b="0">
-                <a:solidFill>
-                  <a:srgbClr val="EAF2FF"/>
-                </a:solidFill>
-                <a:latin typeface="Bitstream Charter"/>
-                <a:ea typeface="Bitstream Charter"/>
-                <a:cs typeface="Bitstream Charter"/>
-              </a:defRPr>
-            </a:pPr>
-          </a:p>
-          <a:p xmlns:a="http://schemas.openxmlformats.org/drawingml/2006/main">
-            <a:pPr>
-              <a:defRPr sz="1500" b="0">
-                <a:solidFill>
-                  <a:srgbClr val="EAF2FF"/>
-                </a:solidFill>
-                <a:latin typeface="Bitstream Charter"/>
-                <a:ea typeface="Bitstream Charter"/>
-                <a:cs typeface="Bitstream Charter"/>
-              </a:defRPr>
-            </a:pPr>
-          </a:p>
-        </p:txBody>
-      </p:sp>
-      <p:sp>
-        <p:nvSpPr>
-          <p:cNvPr id="9" name="">
-            <a:extLst xmlns:a="http://schemas.openxmlformats.org/drawingml/2006/main">
-              <a:ext uri="{FF2B5EF4-FFF2-40B4-BE49-F238E27FC236}">
-                <a16:creationId xmlns:a16="http://schemas.microsoft.com/office/drawing/2014/main" id="{8D06E7F7-A951-4E2E-9FCB-EEB4DE301C2C}"/>
-              </a:ext>
-            </a:extLst>
-          </p:cNvPr>
-          <p:cNvSpPr>
-            <a:spLocks xmlns:a="http://schemas.openxmlformats.org/drawingml/2006/main" noGrp="1"/>
-          </p:cNvSpPr>
-          <p:nvPr/>
-        </p:nvSpPr>
-        <p:spPr>
-          <a:xfrm xmlns:a="http://schemas.openxmlformats.org/drawingml/2006/main">
-            <a:off x="762000" y="4476750"/>
-            <a:ext cx="10287000" cy="609600"/>
-          </a:xfrm>
-          <a:prstGeom xmlns:a="http://schemas.openxmlformats.org/drawingml/2006/main" prst="rect">
+          <a:lstStyle/>
+          <a:p>
+            <a:pPr algn="ctr"/>
+            <a:r>
+              <a:rPr sz="1300">
+                <a:solidFill>
+                  <a:srgbClr val="C7DCEE"/>
+                </a:solidFill>
+                <a:latin typeface="Aptos"/>
+              </a:rPr>
+              <a:t>Caldera → Sandcat Windows · Tailscale · HTTP 8888</a:t>
+            </a:r>
+          </a:p>
+        </p:txBody>
+      </p:sp>
+      <p:cxnSp xmlns:a="http://schemas.openxmlformats.org/drawingml/2006/main">
+        <p:nvCxnSpPr>
+          <p:cNvPr id="25" name="Connector 24"/>
+          <p:cNvCxnSpPr/>
+          <p:nvPr/>
+        </p:nvCxnSpPr>
+        <p:spPr>
+          <a:xfrm>
+            <a:off x="4645152" y="5065776"/>
+            <a:ext cx="5321808" cy="0"/>
+          </a:xfrm>
+          <a:prstGeom prst="line">
             <a:avLst/>
           </a:prstGeom>
-          <a:noFill xmlns:a="http://schemas.openxmlformats.org/drawingml/2006/main"/>
-          <a:ln xmlns:a="http://schemas.openxmlformats.org/drawingml/2006/main" w="0">
-            <a:noFill/>
-          </a:ln>
-        </p:spPr>
-        <p:txBody>
-          <a:bodyPr xmlns:a="http://schemas.openxmlformats.org/drawingml/2006/main">
-            <a:normAutofit fontScale="98551"/>
+          <a:ln w="25400">
+            <a:solidFill>
+              <a:srgbClr val="4ADAAD"/>
+            </a:solidFill>
+            <a:tailEnd type="triangle"/>
+          </a:ln>
+        </p:spPr>
+        <p:style>
+          <a:lnRef idx="2">
+            <a:schemeClr val="accent1"/>
+          </a:lnRef>
+          <a:fillRef idx="0">
+            <a:schemeClr val="accent1"/>
+          </a:fillRef>
+          <a:effectRef idx="1">
+            <a:schemeClr val="accent1"/>
+          </a:effectRef>
+          <a:fontRef idx="minor">
+            <a:schemeClr val="tx1"/>
+          </a:fontRef>
+        </p:style>
+      </p:cxnSp>
+      <p:sp xmlns:a="http://schemas.openxmlformats.org/drawingml/2006/main">
+        <p:nvSpPr>
+          <p:cNvPr id="26" name="TextBox 25"/>
+          <p:cNvSpPr txBox="1"/>
+          <p:nvPr/>
+        </p:nvSpPr>
+        <p:spPr>
+          <a:xfrm>
+            <a:off x="4160520" y="4736592"/>
+            <a:ext cx="5989320" cy="301752"/>
+          </a:xfrm>
+          <a:prstGeom prst="rect">
+            <a:avLst/>
+          </a:prstGeom>
+          <a:noFill/>
+        </p:spPr>
+        <p:txBody>
+          <a:bodyPr wrap="none" lIns="0" rIns="0">
+            <a:spAutoFit/>
           </a:bodyPr>
-          <a:lstStyle xmlns:a="http://schemas.openxmlformats.org/drawingml/2006/main"/>
-          <a:p xmlns:a="http://schemas.openxmlformats.org/drawingml/2006/main">
-            <a:pPr>
-              <a:defRPr sz="1725" b="0">
-                <a:solidFill>
-                  <a:srgbClr val="EAF2FF"/>
-                </a:solidFill>
-                <a:latin typeface="Bitstream Charter"/>
-                <a:ea typeface="Bitstream Charter"/>
-                <a:cs typeface="Bitstream Charter"/>
-              </a:defRPr>
-            </a:pPr>
-            <a:r>
-              <a:rPr sz="1725" b="0">
-                <a:solidFill>
-                  <a:srgbClr val="EAF2FF"/>
-                </a:solidFill>
-                <a:latin typeface="Bitstream Charter"/>
-                <a:ea typeface="Bitstream Charter"/>
-                <a:cs typeface="Bitstream Charter"/>
-              </a:rPr>
-              <a:t>Flux privés : Caldera → Sandcat HTTP 8888 via Tailscale ; agents → Wazuh TCP 1514 via Tailscale (Linux) ou réseau host-only (Windows).</a:t>
+          <a:lstStyle/>
+          <a:p>
+            <a:pPr algn="ctr"/>
+            <a:r>
+              <a:rPr sz="1300">
+                <a:solidFill>
+                  <a:srgbClr val="C7DCEE"/>
+                </a:solidFill>
+                <a:latin typeface="Aptos"/>
+              </a:rPr>
+              <a:t>auditd Linux → Wazuh · Tailscale · TCP 1514</a:t>
+            </a:r>
+          </a:p>
+        </p:txBody>
+      </p:sp>
+      <p:sp xmlns:a="http://schemas.openxmlformats.org/drawingml/2006/main">
+        <p:nvSpPr>
+          <p:cNvPr id="27" name="TextBox 26"/>
+          <p:cNvSpPr txBox="1"/>
+          <p:nvPr/>
+        </p:nvSpPr>
+        <p:spPr>
+          <a:xfrm>
+            <a:off x="6400800" y="5349240"/>
+            <a:ext cx="4663440" cy="301752"/>
+          </a:xfrm>
+          <a:prstGeom prst="rect">
+            <a:avLst/>
+          </a:prstGeom>
+          <a:noFill/>
+        </p:spPr>
+        <p:txBody>
+          <a:bodyPr wrap="none" lIns="0" rIns="0">
+            <a:spAutoFit/>
+          </a:bodyPr>
+          <a:lstStyle/>
+          <a:p>
+            <a:pPr algn="ctr"/>
+            <a:r>
+              <a:rPr sz="1200">
+                <a:solidFill>
+                  <a:srgbClr val="C7DCEE"/>
+                </a:solidFill>
+                <a:latin typeface="Aptos"/>
+              </a:rPr>
+              <a:t>Poste hôte : HTTPS 192.168.56.105 ; WSL → Caldera par SSH</a:t>
             </a:r>
           </a:p>
         </p:txBody>

</xml_diff>